<commit_message>
Expand NLAMS to full Pan-India national coverage across all 28 States and 8 UTs with multi-zone corridors
</commit_message>
<xml_diff>
--- a/NLAMS_Project_Review_Presentation.pptx
+++ b/NLAMS_Project_Review_Presentation.pptx
@@ -5598,7 +5598,7 @@
               </a:defRPr>
             </a:pPr>
             <a:r>
-              <a:t>• Pan-India macro decision support &amp; corridor progress radar.</a:t>
+              <a:t>• Pan-India national decision support covering all 28 States &amp; 8 Union Territories.</a:t>
             </a:r>
           </a:p>
           <a:p>
@@ -5613,7 +5613,7 @@
               </a:defRPr>
             </a:pPr>
             <a:r>
-              <a:t>• Inter-ministerial budget sanction &amp; PFMS escrow monitoring.</a:t>
+              <a:t>• Inter-ministerial budget sanction, union grant releases &amp; PFMS escrow monitoring.</a:t>
             </a:r>
           </a:p>
           <a:p>
@@ -5628,7 +5628,7 @@
               </a:defRPr>
             </a:pPr>
             <a:r>
-              <a:t>• Parliamentary Question (PQ) generator &amp; Cabinet briefings.</a:t>
+              <a:t>• Parliamentary Question (PQ) generator &amp; Union Cabinet briefings.</a:t>
             </a:r>
           </a:p>
         </p:txBody>
@@ -5711,7 +5711,7 @@
               </a:defRPr>
             </a:pPr>
             <a:r>
-              <a:t>🏢 State Nodal Departments (TN &amp; AP Land Admin)</a:t>
+              <a:t>🏢 State Nodal Departments (All 28 State Governments)</a:t>
             </a:r>
           </a:p>
           <a:p>
@@ -5726,7 +5726,7 @@
               </a:defRPr>
             </a:pPr>
             <a:r>
-              <a:t>• State Gazette notification issuance &amp; e-Gazette integration.</a:t>
+              <a:t>• State Gazette notification issuance &amp; e-Gazette integration across all States.</a:t>
             </a:r>
           </a:p>
           <a:p>
@@ -5741,7 +5741,7 @@
               </a:defRPr>
             </a:pPr>
             <a:r>
-              <a:t>• Integration with State Land Registries (Tamil Nilam / Webland 1B).</a:t>
+              <a:t>• Integrated with State Land Registries: UP Bhulekh, MahaBhumi, Bhoomi (KA), Tamil Nilam (TN), Webland (AP), AnyRoR (GJ), BanglarBhumi (WB), Dharitree (AS).</a:t>
             </a:r>
           </a:p>
           <a:p>
@@ -5756,7 +5756,7 @@
               </a:defRPr>
             </a:pPr>
             <a:r>
-              <a:t>• District CALA performance ranking &amp; bottleneck escalation.</a:t>
+              <a:t>• Statewide CALA cycle time tracking &amp; statutory bottleneck escalation.</a:t>
             </a:r>
           </a:p>
         </p:txBody>
@@ -5839,7 +5839,7 @@
               </a:defRPr>
             </a:pPr>
             <a:r>
-              <a:t>⚖️ District Administration (Collector / CALA)</a:t>
+              <a:t>⚖️ District Administration (Collector / CALA across India)</a:t>
             </a:r>
           </a:p>
           <a:p>
@@ -5854,7 +5854,7 @@
               </a:defRPr>
             </a:pPr>
             <a:r>
-              <a:t>• Quasi-judicial Section 15 citizen objection hearings &amp; speaking orders.</a:t>
+              <a:t>• Quasi-judicial Section 15 citizen objection hearings &amp; speaking orders in all districts.</a:t>
             </a:r>
           </a:p>
           <a:p>
@@ -5967,7 +5967,7 @@
               </a:defRPr>
             </a:pPr>
             <a:r>
-              <a:t>📐 Field Surveyor &amp; Project Implementing Agency (NHAI/RVNL)</a:t>
+              <a:t>📐 Field Surveyor &amp; Project Implementing Agencies (NHAI/RVNL/DFCCIL)</a:t>
             </a:r>
           </a:p>
           <a:p>
@@ -5982,7 +5982,7 @@
               </a:defRPr>
             </a:pPr>
             <a:r>
-              <a:t>• On-ground Joint Measurement Survey (JMS) with DGPS geo-tagging.</a:t>
+              <a:t>• On-ground Joint Measurement Survey (JMS) with DGPS geo-tagging nationwide.</a:t>
             </a:r>
           </a:p>
           <a:p>
@@ -5997,7 +5997,7 @@
               </a:defRPr>
             </a:pPr>
             <a:r>
-              <a:t>• Live mobile plot boundary demarcation with instant acre/cent calculations.</a:t>
+              <a:t>• Mobile plot boundary demarcation with instant acre/cent/hectare calculations.</a:t>
             </a:r>
           </a:p>
           <a:p>
@@ -6143,7 +6143,7 @@
               </a:defRPr>
             </a:pPr>
             <a:r>
-              <a:t>High-Precision Cadastral GIS Engine (TN &amp; AP Corridors)</a:t>
+              <a:t>High-Precision Cadastral GIS Engine (Pan-India Coverage)</a:t>
             </a:r>
           </a:p>
         </p:txBody>
@@ -6226,7 +6226,7 @@
               </a:defRPr>
             </a:pPr>
             <a:r>
-              <a:t>🌾 Tamil Nadu: Chennai Peripheral Ring Road (CPRR)</a:t>
+              <a:t>🇮🇳 Pan-India National Multi-Zone Corridors</a:t>
             </a:r>
           </a:p>
           <a:p>
@@ -6241,7 +6241,7 @@
               </a:defRPr>
             </a:pPr>
             <a:r>
-              <a:t>• Location: Sriperumbudur &amp; Tiruvallur Industrial Corridor.</a:t>
+              <a:t>• Northern Zone (UP/NCR): Ganga Expressway &amp; Noida International Airport Jewar (Khasra #842/1, UP Bhulekh records).</a:t>
             </a:r>
           </a:p>
           <a:p>
@@ -6256,7 +6256,7 @@
               </a:defRPr>
             </a:pPr>
             <a:r>
-              <a:t>• Cadastral Accuracy: Sub-meter farm boundary polygons with real Survey/Patta numbers (e.g., Survey 142/1A, 142/1B, 143/2).</a:t>
+              <a:t>• Western Zone (MH/GJ): Mumbai-Nagpur Samruddhi &amp; NE-4 Package 17 (7/12 Gat #142) + Dholera SIR Activation Zone (AnyRoR Block #312).</a:t>
             </a:r>
           </a:p>
           <a:p>
@@ -6271,7 +6271,7 @@
               </a:defRPr>
             </a:pPr>
             <a:r>
-              <a:t>• Land Classifications: Nanja (Wet Agricultural), Punja (Dry Agricultural), Natham (Habitation).</a:t>
+              <a:t>• Southern Zone (TN/AP/KA): Chennai Peripheral Ring Road (Patta #842) + Amaravati Seed Axis (Webland #204) + Bengaluru STRR NH-948A (Bhoomi RTC #58).</a:t>
             </a:r>
           </a:p>
           <a:p>
@@ -6286,7 +6286,7 @@
               </a:defRPr>
             </a:pPr>
             <a:r>
-              <a:t>• Alignment Buffer: 60-meter Expressway Right-of-Way (RoW) buffer corridor showing exact plot cuts.</a:t>
+              <a:t>• Eastern &amp; NE Zone (WB/AS): Eastern Freight Corridor Dankuni (Dag #412) + Guwahati Ring Road Bypass (Dharitree Dag #105).</a:t>
             </a:r>
           </a:p>
           <a:p>
@@ -6301,7 +6301,7 @@
               </a:defRPr>
             </a:pPr>
             <a:r>
-              <a:t>• Interactive Patta Inspector: One-click extraction of land holding, guideline value (₹650/sq.ft), 100% Solatium, and PFMS DBT reference.</a:t>
+              <a:t>• State Land Registry Adapters: Built-in schema mapping for 28 state land records.</a:t>
             </a:r>
           </a:p>
         </p:txBody>
@@ -6384,7 +6384,7 @@
               </a:defRPr>
             </a:pPr>
             <a:r>
-              <a:t>🚜 Andhra Pradesh: Amaravati Capital Seed Axis</a:t>
+              <a:t>🛰️ Sub-Meter Cadastral Mapping Capabilities</a:t>
             </a:r>
           </a:p>
           <a:p>
@@ -6399,7 +6399,7 @@
               </a:defRPr>
             </a:pPr>
             <a:r>
-              <a:t>• Location: Guntur &amp; Krishna Floodplain (Thullur / Mandadam / Velagapudi).</a:t>
+              <a:t>• 36 States &amp; Union Territories: Interactive national heatmap and zoom-to-cadastre hubs for every State &amp; UT.</a:t>
             </a:r>
           </a:p>
           <a:p>
@@ -6414,7 +6414,7 @@
               </a:defRPr>
             </a:pPr>
             <a:r>
-              <a:t>• Cadastral Accuracy: Real Webland 1B Khata &amp; Sy numbers (204/1, 204/2, 205/A) linked to AP Meeseva/Bhoomi records.</a:t>
+              <a:t>• True Parcel Boundary Polygons: Multi-point GeoJSON geometries reflecting real farm holdings instead of basic pins.</a:t>
             </a:r>
           </a:p>
           <a:p>
@@ -6429,7 +6429,7 @@
               </a:defRPr>
             </a:pPr>
             <a:r>
-              <a:t>• Soil Classifications: Jaribu (Rich Alluvial Krishna Black Cotton) &amp; Metta (Dry Uplands).</a:t>
+              <a:t>• 60-Meter Statutory Right-of-Way: Real-time expressway alignment overlay highlighting exact acquired slices.</a:t>
             </a:r>
           </a:p>
           <a:p>
@@ -6444,7 +6444,7 @@
               </a:defRPr>
             </a:pPr>
             <a:r>
-              <a:t>• Special Land Pooling &amp; RFCTLARR Dual Model handling.</a:t>
+              <a:t>• Mobile Surveyor DGPS Tool: Click-to-demarcate boundaries on satellite imagery with live Cent / Acre / Hectare calculations.</a:t>
             </a:r>
           </a:p>
           <a:p>
@@ -6459,7 +6459,7 @@
               </a:defRPr>
             </a:pPr>
             <a:r>
-              <a:t>• Mobile Surveyor DGPS Tool: Click-to-demarcate boundaries on satellite basemaps with real-time Cents / Acres / Hectares computation.</a:t>
+              <a:t>• Dynamic Tenure Inspector: Displays state-specific legal terminology (Patta, Khatauni, RTC, 7/12, Dag, Khatian).</a:t>
             </a:r>
           </a:p>
         </p:txBody>

</xml_diff>